<commit_message>
docs(onboarding): screenshot support in decks (slots + placeholders)
Both renderers now support a per-slide `shot` + `shotCaption`: when the PNG
exists in docs/onboarding/shots it renders as a framed screenshot in a
two-column layout (text left, image right); when absent it renders a labeled
"captura pendiente" placeholder so the slot is visible. Wired 12 process
slides across the Admin, Staff, Finanzas and Comprador decks to their real
app screens, awaiting the captured images.

Co-Authored-By: Claude Opus 4.6 <noreply@anthropic.com>
</commit_message>
<xml_diff>
--- a/docs/onboarding/pptx/02-admin.pptx
+++ b/docs/onboarding/pptx/02-admin.pptx
@@ -3446,7 +3446,7 @@
         <p:spPr>
           <a:xfrm>
             <a:off x="841248" y="1353312"/>
-            <a:ext cx="10509199" cy="868680"/>
+            <a:ext cx="5120640" cy="1280160"/>
           </a:xfrm>
           <a:prstGeom prst="rect">
             <a:avLst/>
@@ -3460,7 +3460,7 @@
           <a:lstStyle/>
           <a:p>
             <a:r>
-              <a:rPr sz="3000" b="1" spc="-40">
+              <a:rPr sz="2700" b="1" spc="-40">
                 <a:solidFill>
                   <a:srgbClr val="0A0A0A"/>
                 </a:solidFill>
@@ -3479,8 +3479,8 @@
         </p:nvSpPr>
         <p:spPr>
           <a:xfrm>
-            <a:off x="841248" y="2194560"/>
-            <a:ext cx="9601200" cy="822960"/>
+            <a:off x="841248" y="2414016"/>
+            <a:ext cx="5120640" cy="1097280"/>
           </a:xfrm>
           <a:prstGeom prst="rect">
             <a:avLst/>
@@ -3495,11 +3495,11 @@
           <a:p>
             <a:pPr>
               <a:lnSpc>
-                <a:spcPct val="135000"/>
+                <a:spcPct val="130000"/>
               </a:lnSpc>
             </a:pPr>
             <a:r>
-              <a:rPr sz="1400" b="0">
+              <a:rPr sz="1300" b="0">
                 <a:solidFill>
                   <a:srgbClr val="52525B"/>
                 </a:solidFill>
@@ -3518,8 +3518,8 @@
         </p:nvSpPr>
         <p:spPr>
           <a:xfrm>
-            <a:off x="841248" y="2651760"/>
-            <a:ext cx="10509199" cy="566928"/>
+            <a:off x="841248" y="3108960"/>
+            <a:ext cx="5120640" cy="713232"/>
           </a:xfrm>
           <a:prstGeom prst="rect">
             <a:avLst/>
@@ -3532,8 +3532,13 @@
           </a:bodyPr>
           <a:lstStyle/>
           <a:p>
-            <a:r>
-              <a:rPr sz="1450" b="1">
+            <a:pPr>
+              <a:lnSpc>
+                <a:spcPct val="125000"/>
+              </a:lnSpc>
+            </a:pPr>
+            <a:r>
+              <a:rPr sz="1300" b="1">
                 <a:solidFill>
                   <a:srgbClr val="0A0A0A"/>
                 </a:solidFill>
@@ -3542,7 +3547,7 @@
               <a:t>Banco y cuenta:  </a:t>
             </a:r>
             <a:r>
-              <a:rPr sz="1450" b="0">
+              <a:rPr sz="1300" b="0">
                 <a:solidFill>
                   <a:srgbClr val="52525B"/>
                 </a:solidFill>
@@ -3555,23 +3560,171 @@
       </p:sp>
       <p:sp>
         <p:nvSpPr>
-          <p:cNvPr id="7" name="Rectangle 6"/>
+          <p:cNvPr id="7" name="TextBox 6"/>
+          <p:cNvSpPr txBox="1"/>
+          <p:nvPr/>
+        </p:nvSpPr>
+        <p:spPr>
+          <a:xfrm>
+            <a:off x="841248" y="3822192"/>
+            <a:ext cx="5120640" cy="713232"/>
+          </a:xfrm>
+          <a:prstGeom prst="rect">
+            <a:avLst/>
+          </a:prstGeom>
+          <a:noFill/>
+        </p:spPr>
+        <p:txBody>
+          <a:bodyPr wrap="square" anchor="ctr" lIns="0" rIns="0" tIns="0" bIns="0">
+            <a:spAutoFit/>
+          </a:bodyPr>
+          <a:lstStyle/>
+          <a:p>
+            <a:pPr>
+              <a:lnSpc>
+                <a:spcPct val="125000"/>
+              </a:lnSpc>
+            </a:pPr>
+            <a:r>
+              <a:rPr sz="1300" b="1">
+                <a:solidFill>
+                  <a:srgbClr val="0A0A0A"/>
+                </a:solidFill>
+                <a:latin typeface="Calibri"/>
+              </a:rPr>
+              <a:t>Seña:  </a:t>
+            </a:r>
+            <a:r>
+              <a:rPr sz="1300" b="0">
+                <a:solidFill>
+                  <a:srgbClr val="52525B"/>
+                </a:solidFill>
+                <a:latin typeface="Calibri"/>
+              </a:rPr>
+              <a:t>porcentaje del valor (por defecto 10%) y plazo en horas para pagar.</a:t>
+            </a:r>
+          </a:p>
+        </p:txBody>
+      </p:sp>
+      <p:sp>
+        <p:nvSpPr>
+          <p:cNvPr id="8" name="TextBox 7"/>
+          <p:cNvSpPr txBox="1"/>
+          <p:nvPr/>
+        </p:nvSpPr>
+        <p:spPr>
+          <a:xfrm>
+            <a:off x="841248" y="4535424"/>
+            <a:ext cx="5120640" cy="713232"/>
+          </a:xfrm>
+          <a:prstGeom prst="rect">
+            <a:avLst/>
+          </a:prstGeom>
+          <a:noFill/>
+        </p:spPr>
+        <p:txBody>
+          <a:bodyPr wrap="square" anchor="ctr" lIns="0" rIns="0" tIns="0" bIns="0">
+            <a:spAutoFit/>
+          </a:bodyPr>
+          <a:lstStyle/>
+          <a:p>
+            <a:pPr>
+              <a:lnSpc>
+                <a:spcPct val="125000"/>
+              </a:lnSpc>
+            </a:pPr>
+            <a:r>
+              <a:rPr sz="1300" b="1">
+                <a:solidFill>
+                  <a:srgbClr val="0A0A0A"/>
+                </a:solidFill>
+                <a:latin typeface="Calibri"/>
+              </a:rPr>
+              <a:t>Instrucciones:  </a:t>
+            </a:r>
+            <a:r>
+              <a:rPr sz="1300" b="0">
+                <a:solidFill>
+                  <a:srgbClr val="52525B"/>
+                </a:solidFill>
+                <a:latin typeface="Calibri"/>
+              </a:rPr>
+              <a:t>texto que guía al comprador, en español e inglés.</a:t>
+            </a:r>
+          </a:p>
+        </p:txBody>
+      </p:sp>
+      <p:sp>
+        <p:nvSpPr>
+          <p:cNvPr id="9" name="TextBox 8"/>
+          <p:cNvSpPr txBox="1"/>
+          <p:nvPr/>
+        </p:nvSpPr>
+        <p:spPr>
+          <a:xfrm>
+            <a:off x="841248" y="5248656"/>
+            <a:ext cx="5120640" cy="713232"/>
+          </a:xfrm>
+          <a:prstGeom prst="rect">
+            <a:avLst/>
+          </a:prstGeom>
+          <a:noFill/>
+        </p:spPr>
+        <p:txBody>
+          <a:bodyPr wrap="square" anchor="ctr" lIns="0" rIns="0" tIns="0" bIns="0">
+            <a:spAutoFit/>
+          </a:bodyPr>
+          <a:lstStyle/>
+          <a:p>
+            <a:pPr>
+              <a:lnSpc>
+                <a:spcPct val="125000"/>
+              </a:lnSpc>
+            </a:pPr>
+            <a:r>
+              <a:rPr sz="1300" b="1">
+                <a:solidFill>
+                  <a:srgbClr val="0A0A0A"/>
+                </a:solidFill>
+                <a:latin typeface="Calibri"/>
+              </a:rPr>
+              <a:t>Contacto:  </a:t>
+            </a:r>
+            <a:r>
+              <a:rPr sz="1300" b="0">
+                <a:solidFill>
+                  <a:srgbClr val="52525B"/>
+                </a:solidFill>
+                <a:latin typeface="Calibri"/>
+              </a:rPr>
+              <a:t>email y teléfono para dudas de pago.</a:t>
+            </a:r>
+          </a:p>
+        </p:txBody>
+      </p:sp>
+      <p:sp>
+        <p:nvSpPr>
+          <p:cNvPr id="10" name="Rounded Rectangle 9"/>
           <p:cNvSpPr/>
           <p:nvPr/>
         </p:nvSpPr>
         <p:spPr>
           <a:xfrm>
-            <a:off x="841248" y="3217788"/>
-            <a:ext cx="10509199" cy="900"/>
-          </a:xfrm>
-          <a:prstGeom prst="rect">
-            <a:avLst/>
+            <a:off x="6419088" y="932688"/>
+            <a:ext cx="4931359" cy="5010912"/>
+          </a:xfrm>
+          <a:prstGeom prst="roundRect">
+            <a:avLst>
+              <a:gd name="adj" fmla="val 4000"/>
+            </a:avLst>
           </a:prstGeom>
           <a:solidFill>
-            <a:srgbClr val="E4E4E7"/>
+            <a:srgbClr val="F1F1F3"/>
           </a:solidFill>
-          <a:ln>
-            <a:noFill/>
+          <a:ln w="12700">
+            <a:solidFill>
+              <a:srgbClr val="A1A1AA"/>
+            </a:solidFill>
           </a:ln>
           <a:effectLst/>
         </p:spPr>
@@ -3590,277 +3743,37 @@
           </a:fontRef>
         </p:style>
         <p:txBody>
-          <a:bodyPr rtlCol="0" anchor="ctr"/>
+          <a:bodyPr rtlCol="0" anchor="ctr" wrap="square"/>
           <a:lstStyle/>
           <a:p>
             <a:pPr algn="ctr"/>
-          </a:p>
-        </p:txBody>
-      </p:sp>
-      <p:sp>
-        <p:nvSpPr>
-          <p:cNvPr id="8" name="TextBox 7"/>
-          <p:cNvSpPr txBox="1"/>
-          <p:nvPr/>
-        </p:nvSpPr>
-        <p:spPr>
-          <a:xfrm>
-            <a:off x="841248" y="3218688"/>
-            <a:ext cx="10509199" cy="566928"/>
-          </a:xfrm>
-          <a:prstGeom prst="rect">
-            <a:avLst/>
-          </a:prstGeom>
-          <a:noFill/>
-        </p:spPr>
-        <p:txBody>
-          <a:bodyPr wrap="square" anchor="ctr" lIns="0" rIns="0" tIns="0" bIns="0">
-            <a:spAutoFit/>
-          </a:bodyPr>
-          <a:lstStyle/>
-          <a:p>
-            <a:r>
-              <a:rPr sz="1450" b="1">
-                <a:solidFill>
-                  <a:srgbClr val="0A0A0A"/>
-                </a:solidFill>
-                <a:latin typeface="Calibri"/>
-              </a:rPr>
-              <a:t>Seña:  </a:t>
-            </a:r>
-            <a:r>
-              <a:rPr sz="1450" b="0">
-                <a:solidFill>
-                  <a:srgbClr val="52525B"/>
-                </a:solidFill>
-                <a:latin typeface="Calibri"/>
-              </a:rPr>
-              <a:t>porcentaje del valor (por defecto 10%) y plazo en horas para pagar.</a:t>
-            </a:r>
-          </a:p>
-        </p:txBody>
-      </p:sp>
-      <p:sp>
-        <p:nvSpPr>
-          <p:cNvPr id="9" name="Rectangle 8"/>
-          <p:cNvSpPr/>
-          <p:nvPr/>
-        </p:nvSpPr>
-        <p:spPr>
-          <a:xfrm>
-            <a:off x="841248" y="3784716"/>
-            <a:ext cx="10509199" cy="900"/>
-          </a:xfrm>
-          <a:prstGeom prst="rect">
-            <a:avLst/>
-          </a:prstGeom>
-          <a:solidFill>
-            <a:srgbClr val="E4E4E7"/>
-          </a:solidFill>
-          <a:ln>
-            <a:noFill/>
-          </a:ln>
-          <a:effectLst/>
-        </p:spPr>
-        <p:style>
-          <a:lnRef idx="1">
-            <a:schemeClr val="accent1"/>
-          </a:lnRef>
-          <a:fillRef idx="3">
-            <a:schemeClr val="accent1"/>
-          </a:fillRef>
-          <a:effectRef idx="2">
-            <a:schemeClr val="accent1"/>
-          </a:effectRef>
-          <a:fontRef idx="minor">
-            <a:schemeClr val="lt1"/>
-          </a:fontRef>
-        </p:style>
-        <p:txBody>
-          <a:bodyPr rtlCol="0" anchor="ctr"/>
-          <a:lstStyle/>
+            <a:r>
+              <a:rPr sz="1200" b="1" spc="120">
+                <a:solidFill>
+                  <a:srgbClr val="71717A"/>
+                </a:solidFill>
+                <a:latin typeface="Calibri"/>
+              </a:rPr>
+              <a:t>CAPTURA PENDIENTE</a:t>
+            </a:r>
+          </a:p>
           <a:p>
             <a:pPr algn="ctr"/>
-          </a:p>
-        </p:txBody>
-      </p:sp>
-      <p:sp>
-        <p:nvSpPr>
-          <p:cNvPr id="10" name="TextBox 9"/>
-          <p:cNvSpPr txBox="1"/>
-          <p:nvPr/>
-        </p:nvSpPr>
-        <p:spPr>
-          <a:xfrm>
-            <a:off x="841248" y="3785616"/>
-            <a:ext cx="10509199" cy="566928"/>
-          </a:xfrm>
-          <a:prstGeom prst="rect">
-            <a:avLst/>
-          </a:prstGeom>
-          <a:noFill/>
-        </p:spPr>
-        <p:txBody>
-          <a:bodyPr wrap="square" anchor="ctr" lIns="0" rIns="0" tIns="0" bIns="0">
-            <a:spAutoFit/>
-          </a:bodyPr>
-          <a:lstStyle/>
-          <a:p>
-            <a:r>
-              <a:rPr sz="1450" b="1">
-                <a:solidFill>
-                  <a:srgbClr val="0A0A0A"/>
-                </a:solidFill>
-                <a:latin typeface="Calibri"/>
-              </a:rPr>
-              <a:t>Instrucciones:  </a:t>
-            </a:r>
-            <a:r>
-              <a:rPr sz="1450" b="0">
-                <a:solidFill>
-                  <a:srgbClr val="52525B"/>
-                </a:solidFill>
-                <a:latin typeface="Calibri"/>
-              </a:rPr>
-              <a:t>texto que guía al comprador, en español e inglés.</a:t>
-            </a:r>
-          </a:p>
-        </p:txBody>
-      </p:sp>
-      <p:sp>
-        <p:nvSpPr>
-          <p:cNvPr id="11" name="Rectangle 10"/>
-          <p:cNvSpPr/>
-          <p:nvPr/>
-        </p:nvSpPr>
-        <p:spPr>
-          <a:xfrm>
-            <a:off x="841248" y="4351644"/>
-            <a:ext cx="10509199" cy="900"/>
-          </a:xfrm>
-          <a:prstGeom prst="rect">
-            <a:avLst/>
-          </a:prstGeom>
-          <a:solidFill>
-            <a:srgbClr val="E4E4E7"/>
-          </a:solidFill>
-          <a:ln>
-            <a:noFill/>
-          </a:ln>
-          <a:effectLst/>
-        </p:spPr>
-        <p:style>
-          <a:lnRef idx="1">
-            <a:schemeClr val="accent1"/>
-          </a:lnRef>
-          <a:fillRef idx="3">
-            <a:schemeClr val="accent1"/>
-          </a:fillRef>
-          <a:effectRef idx="2">
-            <a:schemeClr val="accent1"/>
-          </a:effectRef>
-          <a:fontRef idx="minor">
-            <a:schemeClr val="lt1"/>
-          </a:fontRef>
-        </p:style>
-        <p:txBody>
-          <a:bodyPr rtlCol="0" anchor="ctr"/>
-          <a:lstStyle/>
-          <a:p>
-            <a:pPr algn="ctr"/>
-          </a:p>
-        </p:txBody>
-      </p:sp>
-      <p:sp>
-        <p:nvSpPr>
-          <p:cNvPr id="12" name="TextBox 11"/>
-          <p:cNvSpPr txBox="1"/>
-          <p:nvPr/>
-        </p:nvSpPr>
-        <p:spPr>
-          <a:xfrm>
-            <a:off x="841248" y="4352544"/>
-            <a:ext cx="10509199" cy="566928"/>
-          </a:xfrm>
-          <a:prstGeom prst="rect">
-            <a:avLst/>
-          </a:prstGeom>
-          <a:noFill/>
-        </p:spPr>
-        <p:txBody>
-          <a:bodyPr wrap="square" anchor="ctr" lIns="0" rIns="0" tIns="0" bIns="0">
-            <a:spAutoFit/>
-          </a:bodyPr>
-          <a:lstStyle/>
-          <a:p>
-            <a:r>
-              <a:rPr sz="1450" b="1">
-                <a:solidFill>
-                  <a:srgbClr val="0A0A0A"/>
-                </a:solidFill>
-                <a:latin typeface="Calibri"/>
-              </a:rPr>
-              <a:t>Contacto:  </a:t>
-            </a:r>
-            <a:r>
-              <a:rPr sz="1450" b="0">
-                <a:solidFill>
-                  <a:srgbClr val="52525B"/>
-                </a:solidFill>
-                <a:latin typeface="Calibri"/>
-              </a:rPr>
-              <a:t>email y teléfono para dudas de pago.</a:t>
-            </a:r>
-          </a:p>
-        </p:txBody>
-      </p:sp>
-      <p:sp>
-        <p:nvSpPr>
-          <p:cNvPr id="13" name="Rectangle 12"/>
-          <p:cNvSpPr/>
-          <p:nvPr/>
-        </p:nvSpPr>
-        <p:spPr>
-          <a:xfrm>
-            <a:off x="841248" y="4918572"/>
-            <a:ext cx="10509199" cy="900"/>
-          </a:xfrm>
-          <a:prstGeom prst="rect">
-            <a:avLst/>
-          </a:prstGeom>
-          <a:solidFill>
-            <a:srgbClr val="E4E4E7"/>
-          </a:solidFill>
-          <a:ln>
-            <a:noFill/>
-          </a:ln>
-          <a:effectLst/>
-        </p:spPr>
-        <p:style>
-          <a:lnRef idx="1">
-            <a:schemeClr val="accent1"/>
-          </a:lnRef>
-          <a:fillRef idx="3">
-            <a:schemeClr val="accent1"/>
-          </a:fillRef>
-          <a:effectRef idx="2">
-            <a:schemeClr val="accent1"/>
-          </a:effectRef>
-          <a:fontRef idx="minor">
-            <a:schemeClr val="lt1"/>
-          </a:fontRef>
-        </p:style>
-        <p:txBody>
-          <a:bodyPr rtlCol="0" anchor="ctr"/>
-          <a:lstStyle/>
-          <a:p>
-            <a:pPr algn="ctr"/>
+            <a:r>
+              <a:rPr sz="1050" b="0">
+                <a:solidFill>
+                  <a:srgbClr val="A1A1AA"/>
+                </a:solidFill>
+                <a:latin typeface="Calibri"/>
+              </a:rPr>
+              <a:t>Configuración · sección Pagos</a:t>
+            </a:r>
           </a:p>
         </p:txBody>
       </p:sp>
       <p:pic>
         <p:nvPicPr>
-          <p:cNvPr id="14" name="Picture 13" descr="renew-wordmark-black.png"/>
+          <p:cNvPr id="11" name="Picture 10" descr="renew-wordmark-black.png"/>
           <p:cNvPicPr>
             <a:picLocks noChangeAspect="1"/>
           </p:cNvPicPr>
@@ -3884,7 +3797,7 @@
       </p:pic>
       <p:sp>
         <p:nvSpPr>
-          <p:cNvPr id="15" name="TextBox 14"/>
+          <p:cNvPr id="12" name="TextBox 11"/>
           <p:cNvSpPr txBox="1"/>
           <p:nvPr/>
         </p:nvSpPr>
@@ -6744,7 +6657,7 @@
         <p:spPr>
           <a:xfrm>
             <a:off x="841248" y="1353312"/>
-            <a:ext cx="10509199" cy="868680"/>
+            <a:ext cx="5120640" cy="1280160"/>
           </a:xfrm>
           <a:prstGeom prst="rect">
             <a:avLst/>
@@ -6758,7 +6671,7 @@
           <a:lstStyle/>
           <a:p>
             <a:r>
-              <a:rPr sz="3000" b="1" spc="-40">
+              <a:rPr sz="2700" b="1" spc="-40">
                 <a:solidFill>
                   <a:srgbClr val="0A0A0A"/>
                 </a:solidFill>
@@ -6777,8 +6690,8 @@
         </p:nvSpPr>
         <p:spPr>
           <a:xfrm>
-            <a:off x="841248" y="2194560"/>
-            <a:ext cx="9601200" cy="822960"/>
+            <a:off x="841248" y="1938528"/>
+            <a:ext cx="5120640" cy="1097280"/>
           </a:xfrm>
           <a:prstGeom prst="rect">
             <a:avLst/>
@@ -6793,11 +6706,11 @@
           <a:p>
             <a:pPr>
               <a:lnSpc>
-                <a:spcPct val="135000"/>
+                <a:spcPct val="130000"/>
               </a:lnSpc>
             </a:pPr>
             <a:r>
-              <a:rPr sz="1400" b="0">
+              <a:rPr sz="1300" b="0">
                 <a:solidFill>
                   <a:srgbClr val="52525B"/>
                 </a:solidFill>
@@ -6816,8 +6729,8 @@
         </p:nvSpPr>
         <p:spPr>
           <a:xfrm>
-            <a:off x="841248" y="2651760"/>
-            <a:ext cx="457200" cy="457200"/>
+            <a:off x="841248" y="2633472"/>
+            <a:ext cx="402336" cy="402336"/>
           </a:xfrm>
           <a:prstGeom prst="ellipse">
             <a:avLst/>
@@ -6850,7 +6763,7 @@
           <a:p>
             <a:pPr algn="ctr"/>
             <a:r>
-              <a:rPr sz="1500" b="1">
+              <a:rPr sz="1300" b="1">
                 <a:solidFill>
                   <a:srgbClr val="FFFFFF"/>
                 </a:solidFill>
@@ -6869,8 +6782,8 @@
         </p:nvSpPr>
         <p:spPr>
           <a:xfrm>
-            <a:off x="1554480" y="2633472"/>
-            <a:ext cx="9795967" cy="845820"/>
+            <a:off x="1463040" y="2615184"/>
+            <a:ext cx="4498848" cy="850392"/>
           </a:xfrm>
           <a:prstGeom prst="rect">
             <a:avLst/>
@@ -6884,7 +6797,7 @@
           <a:lstStyle/>
           <a:p>
             <a:r>
-              <a:rPr sz="1500" b="1">
+              <a:rPr sz="1350" b="1">
                 <a:solidFill>
                   <a:srgbClr val="0A0A0A"/>
                 </a:solidFill>
@@ -6896,11 +6809,11 @@
           <a:p>
             <a:pPr>
               <a:lnSpc>
-                <a:spcPct val="128000"/>
+                <a:spcPct val="125000"/>
               </a:lnSpc>
             </a:pPr>
             <a:r>
-              <a:rPr sz="1250" b="0">
+              <a:rPr sz="1100" b="0">
                 <a:solidFill>
                   <a:srgbClr val="52525B"/>
                 </a:solidFill>
@@ -6919,8 +6832,8 @@
         </p:nvSpPr>
         <p:spPr>
           <a:xfrm>
-            <a:off x="841248" y="3497580"/>
-            <a:ext cx="457200" cy="457200"/>
+            <a:off x="841248" y="3483864"/>
+            <a:ext cx="402336" cy="402336"/>
           </a:xfrm>
           <a:prstGeom prst="ellipse">
             <a:avLst/>
@@ -6953,7 +6866,7 @@
           <a:p>
             <a:pPr algn="ctr"/>
             <a:r>
-              <a:rPr sz="1500" b="1">
+              <a:rPr sz="1300" b="1">
                 <a:solidFill>
                   <a:srgbClr val="FFFFFF"/>
                 </a:solidFill>
@@ -6972,8 +6885,8 @@
         </p:nvSpPr>
         <p:spPr>
           <a:xfrm>
-            <a:off x="1554480" y="3479292"/>
-            <a:ext cx="9795967" cy="845820"/>
+            <a:off x="1463040" y="3465576"/>
+            <a:ext cx="4498848" cy="850392"/>
           </a:xfrm>
           <a:prstGeom prst="rect">
             <a:avLst/>
@@ -6987,7 +6900,7 @@
           <a:lstStyle/>
           <a:p>
             <a:r>
-              <a:rPr sz="1500" b="1">
+              <a:rPr sz="1350" b="1">
                 <a:solidFill>
                   <a:srgbClr val="0A0A0A"/>
                 </a:solidFill>
@@ -6999,11 +6912,11 @@
           <a:p>
             <a:pPr>
               <a:lnSpc>
-                <a:spcPct val="128000"/>
+                <a:spcPct val="125000"/>
               </a:lnSpc>
             </a:pPr>
             <a:r>
-              <a:rPr sz="1250" b="0">
+              <a:rPr sz="1100" b="0">
                 <a:solidFill>
                   <a:srgbClr val="52525B"/>
                 </a:solidFill>
@@ -7022,8 +6935,8 @@
         </p:nvSpPr>
         <p:spPr>
           <a:xfrm>
-            <a:off x="841248" y="4343400"/>
-            <a:ext cx="457200" cy="457200"/>
+            <a:off x="841248" y="4334256"/>
+            <a:ext cx="402336" cy="402336"/>
           </a:xfrm>
           <a:prstGeom prst="ellipse">
             <a:avLst/>
@@ -7056,7 +6969,7 @@
           <a:p>
             <a:pPr algn="ctr"/>
             <a:r>
-              <a:rPr sz="1500" b="1">
+              <a:rPr sz="1300" b="1">
                 <a:solidFill>
                   <a:srgbClr val="FFFFFF"/>
                 </a:solidFill>
@@ -7075,8 +6988,8 @@
         </p:nvSpPr>
         <p:spPr>
           <a:xfrm>
-            <a:off x="1554480" y="4325112"/>
-            <a:ext cx="9795967" cy="845820"/>
+            <a:off x="1463040" y="4315968"/>
+            <a:ext cx="4498848" cy="850392"/>
           </a:xfrm>
           <a:prstGeom prst="rect">
             <a:avLst/>
@@ -7090,7 +7003,7 @@
           <a:lstStyle/>
           <a:p>
             <a:r>
-              <a:rPr sz="1500" b="1">
+              <a:rPr sz="1350" b="1">
                 <a:solidFill>
                   <a:srgbClr val="0A0A0A"/>
                 </a:solidFill>
@@ -7102,11 +7015,11 @@
           <a:p>
             <a:pPr>
               <a:lnSpc>
-                <a:spcPct val="128000"/>
+                <a:spcPct val="125000"/>
               </a:lnSpc>
             </a:pPr>
             <a:r>
-              <a:rPr sz="1250" b="0">
+              <a:rPr sz="1100" b="0">
                 <a:solidFill>
                   <a:srgbClr val="52525B"/>
                 </a:solidFill>
@@ -7125,8 +7038,8 @@
         </p:nvSpPr>
         <p:spPr>
           <a:xfrm>
-            <a:off x="841248" y="5189220"/>
-            <a:ext cx="457200" cy="457200"/>
+            <a:off x="841248" y="5184648"/>
+            <a:ext cx="402336" cy="402336"/>
           </a:xfrm>
           <a:prstGeom prst="ellipse">
             <a:avLst/>
@@ -7159,7 +7072,7 @@
           <a:p>
             <a:pPr algn="ctr"/>
             <a:r>
-              <a:rPr sz="1500" b="1">
+              <a:rPr sz="1300" b="1">
                 <a:solidFill>
                   <a:srgbClr val="FFFFFF"/>
                 </a:solidFill>
@@ -7178,8 +7091,8 @@
         </p:nvSpPr>
         <p:spPr>
           <a:xfrm>
-            <a:off x="1554480" y="5170932"/>
-            <a:ext cx="9795967" cy="845820"/>
+            <a:off x="1463040" y="5166360"/>
+            <a:ext cx="4498848" cy="850392"/>
           </a:xfrm>
           <a:prstGeom prst="rect">
             <a:avLst/>
@@ -7193,7 +7106,7 @@
           <a:lstStyle/>
           <a:p>
             <a:r>
-              <a:rPr sz="1500" b="1">
+              <a:rPr sz="1350" b="1">
                 <a:solidFill>
                   <a:srgbClr val="0A0A0A"/>
                 </a:solidFill>
@@ -7205,24 +7118,93 @@
           <a:p>
             <a:pPr>
               <a:lnSpc>
-                <a:spcPct val="128000"/>
+                <a:spcPct val="125000"/>
               </a:lnSpc>
             </a:pPr>
             <a:r>
-              <a:rPr sz="1250" b="0">
+              <a:rPr sz="1100" b="0">
                 <a:solidFill>
                   <a:srgbClr val="52525B"/>
                 </a:solidFill>
                 <a:latin typeface="Calibri"/>
               </a:rPr>
               <a:t>Se crea la cuenta y se envía un correo de bienvenida con un enlace para que la persona cree su contraseña.</a:t>
+            </a:r>
+          </a:p>
+        </p:txBody>
+      </p:sp>
+      <p:sp>
+        <p:nvSpPr>
+          <p:cNvPr id="14" name="Rounded Rectangle 13"/>
+          <p:cNvSpPr/>
+          <p:nvPr/>
+        </p:nvSpPr>
+        <p:spPr>
+          <a:xfrm>
+            <a:off x="6419088" y="932688"/>
+            <a:ext cx="4931359" cy="5010912"/>
+          </a:xfrm>
+          <a:prstGeom prst="roundRect">
+            <a:avLst>
+              <a:gd name="adj" fmla="val 4000"/>
+            </a:avLst>
+          </a:prstGeom>
+          <a:solidFill>
+            <a:srgbClr val="F1F1F3"/>
+          </a:solidFill>
+          <a:ln w="12700">
+            <a:solidFill>
+              <a:srgbClr val="A1A1AA"/>
+            </a:solidFill>
+          </a:ln>
+          <a:effectLst/>
+        </p:spPr>
+        <p:style>
+          <a:lnRef idx="1">
+            <a:schemeClr val="accent1"/>
+          </a:lnRef>
+          <a:fillRef idx="3">
+            <a:schemeClr val="accent1"/>
+          </a:fillRef>
+          <a:effectRef idx="2">
+            <a:schemeClr val="accent1"/>
+          </a:effectRef>
+          <a:fontRef idx="minor">
+            <a:schemeClr val="lt1"/>
+          </a:fontRef>
+        </p:style>
+        <p:txBody>
+          <a:bodyPr rtlCol="0" anchor="ctr" wrap="square"/>
+          <a:lstStyle/>
+          <a:p>
+            <a:pPr algn="ctr"/>
+            <a:r>
+              <a:rPr sz="1200" b="1" spc="120">
+                <a:solidFill>
+                  <a:srgbClr val="71717A"/>
+                </a:solidFill>
+                <a:latin typeface="Calibri"/>
+              </a:rPr>
+              <a:t>CAPTURA PENDIENTE</a:t>
+            </a:r>
+          </a:p>
+          <a:p>
+            <a:pPr algn="ctr"/>
+            <a:r>
+              <a:rPr sz="1050" b="0">
+                <a:solidFill>
+                  <a:srgbClr val="A1A1AA"/>
+                </a:solidFill>
+                <a:latin typeface="Calibri"/>
+              </a:rPr>
+              <a:t>Formulario «Nuevo usuario»</a:t>
             </a:r>
           </a:p>
         </p:txBody>
       </p:sp>
       <p:pic>
         <p:nvPicPr>
-          <p:cNvPr id="14" name="Picture 13" descr="renew-wordmark-black.png"/>
+          <p:cNvPr id="15" name="Picture 14" descr="renew-wordmark-black.png"/>
           <p:cNvPicPr>
             <a:picLocks noChangeAspect="1"/>
           </p:cNvPicPr>
@@ -7246,7 +7228,7 @@
       </p:pic>
       <p:sp>
         <p:nvSpPr>
-          <p:cNvPr id="15" name="TextBox 14"/>
+          <p:cNvPr id="16" name="TextBox 15"/>
           <p:cNvSpPr txBox="1"/>
           <p:nvPr/>
         </p:nvSpPr>
@@ -8634,7 +8616,7 @@
         <p:spPr>
           <a:xfrm>
             <a:off x="841248" y="1353312"/>
-            <a:ext cx="10509199" cy="868680"/>
+            <a:ext cx="5120640" cy="1280160"/>
           </a:xfrm>
           <a:prstGeom prst="rect">
             <a:avLst/>
@@ -8648,7 +8630,7 @@
           <a:lstStyle/>
           <a:p>
             <a:r>
-              <a:rPr sz="3000" b="1" spc="-40">
+              <a:rPr sz="2700" b="1" spc="-40">
                 <a:solidFill>
                   <a:srgbClr val="0A0A0A"/>
                 </a:solidFill>
@@ -8667,8 +8649,8 @@
         </p:nvSpPr>
         <p:spPr>
           <a:xfrm>
-            <a:off x="841248" y="2194560"/>
-            <a:ext cx="9601200" cy="822960"/>
+            <a:off x="841248" y="2414016"/>
+            <a:ext cx="5120640" cy="1097280"/>
           </a:xfrm>
           <a:prstGeom prst="rect">
             <a:avLst/>
@@ -8683,11 +8665,11 @@
           <a:p>
             <a:pPr>
               <a:lnSpc>
-                <a:spcPct val="135000"/>
+                <a:spcPct val="130000"/>
               </a:lnSpc>
             </a:pPr>
             <a:r>
-              <a:rPr sz="1400" b="0">
+              <a:rPr sz="1300" b="0">
                 <a:solidFill>
                   <a:srgbClr val="52525B"/>
                 </a:solidFill>
@@ -8706,8 +8688,8 @@
         </p:nvSpPr>
         <p:spPr>
           <a:xfrm>
-            <a:off x="841248" y="2651760"/>
-            <a:ext cx="457200" cy="457200"/>
+            <a:off x="841248" y="3108960"/>
+            <a:ext cx="402336" cy="402336"/>
           </a:xfrm>
           <a:prstGeom prst="ellipse">
             <a:avLst/>
@@ -8740,7 +8722,7 @@
           <a:p>
             <a:pPr algn="ctr"/>
             <a:r>
-              <a:rPr sz="1500" b="1">
+              <a:rPr sz="1300" b="1">
                 <a:solidFill>
                   <a:srgbClr val="FFFFFF"/>
                 </a:solidFill>
@@ -8759,8 +8741,8 @@
         </p:nvSpPr>
         <p:spPr>
           <a:xfrm>
-            <a:off x="1554480" y="2633472"/>
-            <a:ext cx="9795967" cy="960120"/>
+            <a:off x="1463040" y="3090672"/>
+            <a:ext cx="4498848" cy="914400"/>
           </a:xfrm>
           <a:prstGeom prst="rect">
             <a:avLst/>
@@ -8774,7 +8756,7 @@
           <a:lstStyle/>
           <a:p>
             <a:r>
-              <a:rPr sz="1500" b="1">
+              <a:rPr sz="1350" b="1">
                 <a:solidFill>
                   <a:srgbClr val="0A0A0A"/>
                 </a:solidFill>
@@ -8786,11 +8768,11 @@
           <a:p>
             <a:pPr>
               <a:lnSpc>
-                <a:spcPct val="128000"/>
+                <a:spcPct val="125000"/>
               </a:lnSpc>
             </a:pPr>
             <a:r>
-              <a:rPr sz="1250" b="0">
+              <a:rPr sz="1100" b="0">
                 <a:solidFill>
                   <a:srgbClr val="52525B"/>
                 </a:solidFill>
@@ -8809,8 +8791,8 @@
         </p:nvSpPr>
         <p:spPr>
           <a:xfrm>
-            <a:off x="841248" y="3611880"/>
-            <a:ext cx="457200" cy="457200"/>
+            <a:off x="841248" y="4023360"/>
+            <a:ext cx="402336" cy="402336"/>
           </a:xfrm>
           <a:prstGeom prst="ellipse">
             <a:avLst/>
@@ -8843,7 +8825,7 @@
           <a:p>
             <a:pPr algn="ctr"/>
             <a:r>
-              <a:rPr sz="1500" b="1">
+              <a:rPr sz="1300" b="1">
                 <a:solidFill>
                   <a:srgbClr val="FFFFFF"/>
                 </a:solidFill>
@@ -8862,8 +8844,8 @@
         </p:nvSpPr>
         <p:spPr>
           <a:xfrm>
-            <a:off x="1554480" y="3593592"/>
-            <a:ext cx="9795967" cy="960120"/>
+            <a:off x="1463040" y="4005072"/>
+            <a:ext cx="4498848" cy="914400"/>
           </a:xfrm>
           <a:prstGeom prst="rect">
             <a:avLst/>
@@ -8877,7 +8859,7 @@
           <a:lstStyle/>
           <a:p>
             <a:r>
-              <a:rPr sz="1500" b="1">
+              <a:rPr sz="1350" b="1">
                 <a:solidFill>
                   <a:srgbClr val="0A0A0A"/>
                 </a:solidFill>
@@ -8889,11 +8871,11 @@
           <a:p>
             <a:pPr>
               <a:lnSpc>
-                <a:spcPct val="128000"/>
+                <a:spcPct val="125000"/>
               </a:lnSpc>
             </a:pPr>
             <a:r>
-              <a:rPr sz="1250" b="0">
+              <a:rPr sz="1100" b="0">
                 <a:solidFill>
                   <a:srgbClr val="52525B"/>
                 </a:solidFill>
@@ -8912,8 +8894,8 @@
         </p:nvSpPr>
         <p:spPr>
           <a:xfrm>
-            <a:off x="841248" y="4572000"/>
-            <a:ext cx="457200" cy="457200"/>
+            <a:off x="841248" y="4937760"/>
+            <a:ext cx="402336" cy="402336"/>
           </a:xfrm>
           <a:prstGeom prst="ellipse">
             <a:avLst/>
@@ -8946,7 +8928,7 @@
           <a:p>
             <a:pPr algn="ctr"/>
             <a:r>
-              <a:rPr sz="1500" b="1">
+              <a:rPr sz="1300" b="1">
                 <a:solidFill>
                   <a:srgbClr val="FFFFFF"/>
                 </a:solidFill>
@@ -8965,8 +8947,8 @@
         </p:nvSpPr>
         <p:spPr>
           <a:xfrm>
-            <a:off x="1554480" y="4553712"/>
-            <a:ext cx="9795967" cy="960120"/>
+            <a:off x="1463040" y="4919472"/>
+            <a:ext cx="4498848" cy="914400"/>
           </a:xfrm>
           <a:prstGeom prst="rect">
             <a:avLst/>
@@ -8980,7 +8962,7 @@
           <a:lstStyle/>
           <a:p>
             <a:r>
-              <a:rPr sz="1500" b="1">
+              <a:rPr sz="1350" b="1">
                 <a:solidFill>
                   <a:srgbClr val="0A0A0A"/>
                 </a:solidFill>
@@ -8992,24 +8974,93 @@
           <a:p>
             <a:pPr>
               <a:lnSpc>
-                <a:spcPct val="128000"/>
+                <a:spcPct val="125000"/>
               </a:lnSpc>
             </a:pPr>
             <a:r>
-              <a:rPr sz="1250" b="0">
+              <a:rPr sz="1100" b="0">
                 <a:solidFill>
                   <a:srgbClr val="52525B"/>
                 </a:solidFill>
                 <a:latin typeface="Calibri"/>
               </a:rPr>
               <a:t>Borra la cuenta. Pide confirmación porque es una acción definitiva.</a:t>
+            </a:r>
+          </a:p>
+        </p:txBody>
+      </p:sp>
+      <p:sp>
+        <p:nvSpPr>
+          <p:cNvPr id="12" name="Rounded Rectangle 11"/>
+          <p:cNvSpPr/>
+          <p:nvPr/>
+        </p:nvSpPr>
+        <p:spPr>
+          <a:xfrm>
+            <a:off x="6419088" y="932688"/>
+            <a:ext cx="4931359" cy="5010912"/>
+          </a:xfrm>
+          <a:prstGeom prst="roundRect">
+            <a:avLst>
+              <a:gd name="adj" fmla="val 4000"/>
+            </a:avLst>
+          </a:prstGeom>
+          <a:solidFill>
+            <a:srgbClr val="F1F1F3"/>
+          </a:solidFill>
+          <a:ln w="12700">
+            <a:solidFill>
+              <a:srgbClr val="A1A1AA"/>
+            </a:solidFill>
+          </a:ln>
+          <a:effectLst/>
+        </p:spPr>
+        <p:style>
+          <a:lnRef idx="1">
+            <a:schemeClr val="accent1"/>
+          </a:lnRef>
+          <a:fillRef idx="3">
+            <a:schemeClr val="accent1"/>
+          </a:fillRef>
+          <a:effectRef idx="2">
+            <a:schemeClr val="accent1"/>
+          </a:effectRef>
+          <a:fontRef idx="minor">
+            <a:schemeClr val="lt1"/>
+          </a:fontRef>
+        </p:style>
+        <p:txBody>
+          <a:bodyPr rtlCol="0" anchor="ctr" wrap="square"/>
+          <a:lstStyle/>
+          <a:p>
+            <a:pPr algn="ctr"/>
+            <a:r>
+              <a:rPr sz="1200" b="1" spc="120">
+                <a:solidFill>
+                  <a:srgbClr val="71717A"/>
+                </a:solidFill>
+                <a:latin typeface="Calibri"/>
+              </a:rPr>
+              <a:t>CAPTURA PENDIENTE</a:t>
+            </a:r>
+          </a:p>
+          <a:p>
+            <a:pPr algn="ctr"/>
+            <a:r>
+              <a:rPr sz="1050" b="0">
+                <a:solidFill>
+                  <a:srgbClr val="A1A1AA"/>
+                </a:solidFill>
+                <a:latin typeface="Calibri"/>
+              </a:rPr>
+              <a:t>Edición de rol y estado</a:t>
             </a:r>
           </a:p>
         </p:txBody>
       </p:sp>
       <p:pic>
         <p:nvPicPr>
-          <p:cNvPr id="12" name="Picture 11" descr="renew-wordmark-black.png"/>
+          <p:cNvPr id="13" name="Picture 12" descr="renew-wordmark-black.png"/>
           <p:cNvPicPr>
             <a:picLocks noChangeAspect="1"/>
           </p:cNvPicPr>
@@ -9033,7 +9084,7 @@
       </p:pic>
       <p:sp>
         <p:nvSpPr>
-          <p:cNvPr id="13" name="TextBox 12"/>
+          <p:cNvPr id="14" name="TextBox 13"/>
           <p:cNvSpPr txBox="1"/>
           <p:nvPr/>
         </p:nvSpPr>

</xml_diff>